<commit_message>
Update frontend, PPT, and Report with DenseNet121 Mega-Dataset details
</commit_message>
<xml_diff>
--- a/Sci_Fi_Brain_Tumor_Presentation.pptx
+++ b/Sci_Fi_Brain_Tumor_Presentation.pptx
@@ -5,13 +5,13 @@
     <p:sldMasterId id="2147483648" r:id="rId1"/>
   </p:sldMasterIdLst>
   <p:sldIdLst>
-    <p:sldId id="256" r:id="rId2"/>
-    <p:sldId id="257" r:id="rId3"/>
-    <p:sldId id="258" r:id="rId4"/>
-    <p:sldId id="259" r:id="rId5"/>
-    <p:sldId id="260" r:id="rId6"/>
-    <p:sldId id="261" r:id="rId7"/>
-    <p:sldId id="262" r:id="rId8"/>
+    <p:sldId id="256" r:id="rId7"/>
+    <p:sldId id="257" r:id="rId8"/>
+    <p:sldId id="258" r:id="rId9"/>
+    <p:sldId id="259" r:id="rId10"/>
+    <p:sldId id="260" r:id="rId11"/>
+    <p:sldId id="261" r:id="rId12"/>
+    <p:sldId id="262" r:id="rId13"/>
   </p:sldIdLst>
   <p:sldSz cx="9144000" cy="6858000" type="screen4x3"/>
   <p:notesSz cx="6858000" cy="9144000"/>
@@ -110,52 +110,7 @@
       </a:defRPr>
     </a:lvl9pPr>
   </p:defaultTextStyle>
-  <p:extLst>
-    <p:ext uri="{EFAFB233-063F-42B5-8137-9DF3F51BA10A}">
-      <p15:sldGuideLst xmlns:p15="http://schemas.microsoft.com/office/powerpoint/2012/main">
-        <p15:guide id="1" orient="horz" pos="2160">
-          <p15:clr>
-            <a:srgbClr val="A4A3A4"/>
-          </p15:clr>
-        </p15:guide>
-        <p15:guide id="2" pos="2880">
-          <p15:clr>
-            <a:srgbClr val="A4A3A4"/>
-          </p15:clr>
-        </p15:guide>
-      </p15:sldGuideLst>
-    </p:ext>
-  </p:extLst>
 </p:presentation>
-</file>
-
-<file path=ppt/changesInfos/changesInfo1.xml><?xml version="1.0" encoding="utf-8"?>
-<pc:chgInfo xmlns:a="http://schemas.openxmlformats.org/drawingml/2006/main" xmlns:r="http://schemas.openxmlformats.org/officeDocument/2006/relationships" xmlns:ac="http://schemas.microsoft.com/office/drawing/2013/main/command" xmlns:pc="http://schemas.microsoft.com/office/powerpoint/2013/main/command">
-  <pc:docChgLst>
-    <pc:chgData name="SHAHIL PRATAP SINGH" userId="59e7c69f61702dbb" providerId="LiveId" clId="{54B313A7-D256-4336-BBE6-8E48C6F2F96A}"/>
-    <pc:docChg chg="modSld">
-      <pc:chgData name="SHAHIL PRATAP SINGH" userId="59e7c69f61702dbb" providerId="LiveId" clId="{54B313A7-D256-4336-BBE6-8E48C6F2F96A}" dt="2026-08-12T19:15:57.684" v="4" actId="20577"/>
-      <pc:docMkLst>
-        <pc:docMk/>
-      </pc:docMkLst>
-      <pc:sldChg chg="modSp mod">
-        <pc:chgData name="SHAHIL PRATAP SINGH" userId="59e7c69f61702dbb" providerId="LiveId" clId="{54B313A7-D256-4336-BBE6-8E48C6F2F96A}" dt="2026-08-12T19:15:57.684" v="4" actId="20577"/>
-        <pc:sldMkLst>
-          <pc:docMk/>
-          <pc:sldMk cId="0" sldId="262"/>
-        </pc:sldMkLst>
-        <pc:spChg chg="mod">
-          <ac:chgData name="SHAHIL PRATAP SINGH" userId="59e7c69f61702dbb" providerId="LiveId" clId="{54B313A7-D256-4336-BBE6-8E48C6F2F96A}" dt="2026-08-12T19:15:57.684" v="4" actId="20577"/>
-          <ac:spMkLst>
-            <pc:docMk/>
-            <pc:sldMk cId="0" sldId="262"/>
-            <ac:spMk id="3" creationId="{00000000-0000-0000-0000-000000000000}"/>
-          </ac:spMkLst>
-        </pc:spChg>
-      </pc:sldChg>
-    </pc:docChg>
-  </pc:docChgLst>
-</pc:chgInfo>
 </file>
 
 <file path=ppt/slideLayouts/slideLayout1.xml><?xml version="1.0" encoding="utf-8"?>
@@ -196,9 +151,10 @@
           <a:lstStyle/>
           <a:p>
             <a:r>
-              <a:rPr lang="en-US"/>
+              <a:rPr lang="en-US" smtClean="0"/>
               <a:t>Click to edit Master title style</a:t>
             </a:r>
+            <a:endParaRPr lang="en-US"/>
           </a:p>
         </p:txBody>
       </p:sp>
@@ -314,9 +270,10 @@
           </a:lstStyle>
           <a:p>
             <a:r>
-              <a:rPr lang="en-US"/>
+              <a:rPr lang="en-US" smtClean="0"/>
               <a:t>Click to edit Master subtitle style</a:t>
             </a:r>
+            <a:endParaRPr lang="en-US"/>
           </a:p>
         </p:txBody>
       </p:sp>
@@ -337,7 +294,7 @@
           <a:p>
             <a:fld id="{5BCAD085-E8A6-8845-BD4E-CB4CCA059FC4}" type="datetimeFigureOut">
               <a:rPr lang="en-US" smtClean="0"/>
-              <a:t>8/13/2026</a:t>
+              <a:t>1/27/13</a:t>
             </a:fld>
             <a:endParaRPr lang="en-US"/>
           </a:p>
@@ -431,9 +388,10 @@
           <a:lstStyle/>
           <a:p>
             <a:r>
-              <a:rPr lang="en-US"/>
+              <a:rPr lang="en-US" smtClean="0"/>
               <a:t>Click to edit Master title style</a:t>
             </a:r>
+            <a:endParaRPr lang="en-US"/>
           </a:p>
         </p:txBody>
       </p:sp>
@@ -454,37 +412,38 @@
           <a:p>
             <a:pPr lvl="0"/>
             <a:r>
-              <a:rPr lang="en-US"/>
+              <a:rPr lang="en-US" smtClean="0"/>
               <a:t>Click to edit Master text styles</a:t>
             </a:r>
           </a:p>
           <a:p>
             <a:pPr lvl="1"/>
             <a:r>
-              <a:rPr lang="en-US"/>
+              <a:rPr lang="en-US" smtClean="0"/>
               <a:t>Second level</a:t>
             </a:r>
           </a:p>
           <a:p>
             <a:pPr lvl="2"/>
             <a:r>
-              <a:rPr lang="en-US"/>
+              <a:rPr lang="en-US" smtClean="0"/>
               <a:t>Third level</a:t>
             </a:r>
           </a:p>
           <a:p>
             <a:pPr lvl="3"/>
             <a:r>
-              <a:rPr lang="en-US"/>
+              <a:rPr lang="en-US" smtClean="0"/>
               <a:t>Fourth level</a:t>
             </a:r>
           </a:p>
           <a:p>
             <a:pPr lvl="4"/>
             <a:r>
-              <a:rPr lang="en-US"/>
+              <a:rPr lang="en-US" smtClean="0"/>
               <a:t>Fifth level</a:t>
             </a:r>
+            <a:endParaRPr lang="en-US"/>
           </a:p>
         </p:txBody>
       </p:sp>
@@ -505,7 +464,7 @@
           <a:p>
             <a:fld id="{5BCAD085-E8A6-8845-BD4E-CB4CCA059FC4}" type="datetimeFigureOut">
               <a:rPr lang="en-US" smtClean="0"/>
-              <a:t>8/13/2026</a:t>
+              <a:t>1/27/13</a:t>
             </a:fld>
             <a:endParaRPr lang="en-US"/>
           </a:p>
@@ -604,9 +563,10 @@
           <a:lstStyle/>
           <a:p>
             <a:r>
-              <a:rPr lang="en-US"/>
+              <a:rPr lang="en-US" smtClean="0"/>
               <a:t>Click to edit Master title style</a:t>
             </a:r>
+            <a:endParaRPr lang="en-US"/>
           </a:p>
         </p:txBody>
       </p:sp>
@@ -632,37 +592,38 @@
           <a:p>
             <a:pPr lvl="0"/>
             <a:r>
-              <a:rPr lang="en-US"/>
+              <a:rPr lang="en-US" smtClean="0"/>
               <a:t>Click to edit Master text styles</a:t>
             </a:r>
           </a:p>
           <a:p>
             <a:pPr lvl="1"/>
             <a:r>
-              <a:rPr lang="en-US"/>
+              <a:rPr lang="en-US" smtClean="0"/>
               <a:t>Second level</a:t>
             </a:r>
           </a:p>
           <a:p>
             <a:pPr lvl="2"/>
             <a:r>
-              <a:rPr lang="en-US"/>
+              <a:rPr lang="en-US" smtClean="0"/>
               <a:t>Third level</a:t>
             </a:r>
           </a:p>
           <a:p>
             <a:pPr lvl="3"/>
             <a:r>
-              <a:rPr lang="en-US"/>
+              <a:rPr lang="en-US" smtClean="0"/>
               <a:t>Fourth level</a:t>
             </a:r>
           </a:p>
           <a:p>
             <a:pPr lvl="4"/>
             <a:r>
-              <a:rPr lang="en-US"/>
+              <a:rPr lang="en-US" smtClean="0"/>
               <a:t>Fifth level</a:t>
             </a:r>
+            <a:endParaRPr lang="en-US"/>
           </a:p>
         </p:txBody>
       </p:sp>
@@ -683,7 +644,7 @@
           <a:p>
             <a:fld id="{5BCAD085-E8A6-8845-BD4E-CB4CCA059FC4}" type="datetimeFigureOut">
               <a:rPr lang="en-US" smtClean="0"/>
-              <a:t>8/13/2026</a:t>
+              <a:t>1/27/13</a:t>
             </a:fld>
             <a:endParaRPr lang="en-US"/>
           </a:p>
@@ -777,9 +738,10 @@
           <a:lstStyle/>
           <a:p>
             <a:r>
-              <a:rPr lang="en-US"/>
+              <a:rPr lang="en-US" smtClean="0"/>
               <a:t>Click to edit Master title style</a:t>
             </a:r>
+            <a:endParaRPr lang="en-US"/>
           </a:p>
         </p:txBody>
       </p:sp>
@@ -800,37 +762,38 @@
           <a:p>
             <a:pPr lvl="0"/>
             <a:r>
-              <a:rPr lang="en-US"/>
+              <a:rPr lang="en-US" smtClean="0"/>
               <a:t>Click to edit Master text styles</a:t>
             </a:r>
           </a:p>
           <a:p>
             <a:pPr lvl="1"/>
             <a:r>
-              <a:rPr lang="en-US"/>
+              <a:rPr lang="en-US" smtClean="0"/>
               <a:t>Second level</a:t>
             </a:r>
           </a:p>
           <a:p>
             <a:pPr lvl="2"/>
             <a:r>
-              <a:rPr lang="en-US"/>
+              <a:rPr lang="en-US" smtClean="0"/>
               <a:t>Third level</a:t>
             </a:r>
           </a:p>
           <a:p>
             <a:pPr lvl="3"/>
             <a:r>
-              <a:rPr lang="en-US"/>
+              <a:rPr lang="en-US" smtClean="0"/>
               <a:t>Fourth level</a:t>
             </a:r>
           </a:p>
           <a:p>
             <a:pPr lvl="4"/>
             <a:r>
-              <a:rPr lang="en-US"/>
+              <a:rPr lang="en-US" smtClean="0"/>
               <a:t>Fifth level</a:t>
             </a:r>
+            <a:endParaRPr lang="en-US"/>
           </a:p>
         </p:txBody>
       </p:sp>
@@ -851,7 +814,7 @@
           <a:p>
             <a:fld id="{5BCAD085-E8A6-8845-BD4E-CB4CCA059FC4}" type="datetimeFigureOut">
               <a:rPr lang="en-US" smtClean="0"/>
-              <a:t>8/13/2026</a:t>
+              <a:t>1/27/13</a:t>
             </a:fld>
             <a:endParaRPr lang="en-US"/>
           </a:p>
@@ -954,9 +917,10 @@
           </a:lstStyle>
           <a:p>
             <a:r>
-              <a:rPr lang="en-US"/>
+              <a:rPr lang="en-US" smtClean="0"/>
               <a:t>Click to edit Master title style</a:t>
             </a:r>
+            <a:endParaRPr lang="en-US"/>
           </a:p>
         </p:txBody>
       </p:sp>
@@ -1073,7 +1037,7 @@
           <a:p>
             <a:pPr lvl="0"/>
             <a:r>
-              <a:rPr lang="en-US"/>
+              <a:rPr lang="en-US" smtClean="0"/>
               <a:t>Click to edit Master text styles</a:t>
             </a:r>
           </a:p>
@@ -1096,7 +1060,7 @@
           <a:p>
             <a:fld id="{5BCAD085-E8A6-8845-BD4E-CB4CCA059FC4}" type="datetimeFigureOut">
               <a:rPr lang="en-US" smtClean="0"/>
-              <a:t>8/13/2026</a:t>
+              <a:t>1/27/13</a:t>
             </a:fld>
             <a:endParaRPr lang="en-US"/>
           </a:p>
@@ -1190,9 +1154,10 @@
           <a:lstStyle/>
           <a:p>
             <a:r>
-              <a:rPr lang="en-US"/>
+              <a:rPr lang="en-US" smtClean="0"/>
               <a:t>Click to edit Master title style</a:t>
             </a:r>
+            <a:endParaRPr lang="en-US"/>
           </a:p>
         </p:txBody>
       </p:sp>
@@ -1246,37 +1211,38 @@
           <a:p>
             <a:pPr lvl="0"/>
             <a:r>
-              <a:rPr lang="en-US"/>
+              <a:rPr lang="en-US" smtClean="0"/>
               <a:t>Click to edit Master text styles</a:t>
             </a:r>
           </a:p>
           <a:p>
             <a:pPr lvl="1"/>
             <a:r>
-              <a:rPr lang="en-US"/>
+              <a:rPr lang="en-US" smtClean="0"/>
               <a:t>Second level</a:t>
             </a:r>
           </a:p>
           <a:p>
             <a:pPr lvl="2"/>
             <a:r>
-              <a:rPr lang="en-US"/>
+              <a:rPr lang="en-US" smtClean="0"/>
               <a:t>Third level</a:t>
             </a:r>
           </a:p>
           <a:p>
             <a:pPr lvl="3"/>
             <a:r>
-              <a:rPr lang="en-US"/>
+              <a:rPr lang="en-US" smtClean="0"/>
               <a:t>Fourth level</a:t>
             </a:r>
           </a:p>
           <a:p>
             <a:pPr lvl="4"/>
             <a:r>
-              <a:rPr lang="en-US"/>
+              <a:rPr lang="en-US" smtClean="0"/>
               <a:t>Fifth level</a:t>
             </a:r>
+            <a:endParaRPr lang="en-US"/>
           </a:p>
         </p:txBody>
       </p:sp>
@@ -1330,37 +1296,38 @@
           <a:p>
             <a:pPr lvl="0"/>
             <a:r>
-              <a:rPr lang="en-US"/>
+              <a:rPr lang="en-US" smtClean="0"/>
               <a:t>Click to edit Master text styles</a:t>
             </a:r>
           </a:p>
           <a:p>
             <a:pPr lvl="1"/>
             <a:r>
-              <a:rPr lang="en-US"/>
+              <a:rPr lang="en-US" smtClean="0"/>
               <a:t>Second level</a:t>
             </a:r>
           </a:p>
           <a:p>
             <a:pPr lvl="2"/>
             <a:r>
-              <a:rPr lang="en-US"/>
+              <a:rPr lang="en-US" smtClean="0"/>
               <a:t>Third level</a:t>
             </a:r>
           </a:p>
           <a:p>
             <a:pPr lvl="3"/>
             <a:r>
-              <a:rPr lang="en-US"/>
+              <a:rPr lang="en-US" smtClean="0"/>
               <a:t>Fourth level</a:t>
             </a:r>
           </a:p>
           <a:p>
             <a:pPr lvl="4"/>
             <a:r>
-              <a:rPr lang="en-US"/>
+              <a:rPr lang="en-US" smtClean="0"/>
               <a:t>Fifth level</a:t>
             </a:r>
+            <a:endParaRPr lang="en-US"/>
           </a:p>
         </p:txBody>
       </p:sp>
@@ -1381,7 +1348,7 @@
           <a:p>
             <a:fld id="{5BCAD085-E8A6-8845-BD4E-CB4CCA059FC4}" type="datetimeFigureOut">
               <a:rPr lang="en-US" smtClean="0"/>
-              <a:t>8/13/2026</a:t>
+              <a:t>1/27/13</a:t>
             </a:fld>
             <a:endParaRPr lang="en-US"/>
           </a:p>
@@ -1479,9 +1446,10 @@
           </a:lstStyle>
           <a:p>
             <a:r>
-              <a:rPr lang="en-US"/>
+              <a:rPr lang="en-US" smtClean="0"/>
               <a:t>Click to edit Master title style</a:t>
             </a:r>
+            <a:endParaRPr lang="en-US"/>
           </a:p>
         </p:txBody>
       </p:sp>
@@ -1544,7 +1512,7 @@
           <a:p>
             <a:pPr lvl="0"/>
             <a:r>
-              <a:rPr lang="en-US"/>
+              <a:rPr lang="en-US" smtClean="0"/>
               <a:t>Click to edit Master text styles</a:t>
             </a:r>
           </a:p>
@@ -1600,37 +1568,38 @@
           <a:p>
             <a:pPr lvl="0"/>
             <a:r>
-              <a:rPr lang="en-US"/>
+              <a:rPr lang="en-US" smtClean="0"/>
               <a:t>Click to edit Master text styles</a:t>
             </a:r>
           </a:p>
           <a:p>
             <a:pPr lvl="1"/>
             <a:r>
-              <a:rPr lang="en-US"/>
+              <a:rPr lang="en-US" smtClean="0"/>
               <a:t>Second level</a:t>
             </a:r>
           </a:p>
           <a:p>
             <a:pPr lvl="2"/>
             <a:r>
-              <a:rPr lang="en-US"/>
+              <a:rPr lang="en-US" smtClean="0"/>
               <a:t>Third level</a:t>
             </a:r>
           </a:p>
           <a:p>
             <a:pPr lvl="3"/>
             <a:r>
-              <a:rPr lang="en-US"/>
+              <a:rPr lang="en-US" smtClean="0"/>
               <a:t>Fourth level</a:t>
             </a:r>
           </a:p>
           <a:p>
             <a:pPr lvl="4"/>
             <a:r>
-              <a:rPr lang="en-US"/>
+              <a:rPr lang="en-US" smtClean="0"/>
               <a:t>Fifth level</a:t>
             </a:r>
+            <a:endParaRPr lang="en-US"/>
           </a:p>
         </p:txBody>
       </p:sp>
@@ -1693,7 +1662,7 @@
           <a:p>
             <a:pPr lvl="0"/>
             <a:r>
-              <a:rPr lang="en-US"/>
+              <a:rPr lang="en-US" smtClean="0"/>
               <a:t>Click to edit Master text styles</a:t>
             </a:r>
           </a:p>
@@ -1749,37 +1718,38 @@
           <a:p>
             <a:pPr lvl="0"/>
             <a:r>
-              <a:rPr lang="en-US"/>
+              <a:rPr lang="en-US" smtClean="0"/>
               <a:t>Click to edit Master text styles</a:t>
             </a:r>
           </a:p>
           <a:p>
             <a:pPr lvl="1"/>
             <a:r>
-              <a:rPr lang="en-US"/>
+              <a:rPr lang="en-US" smtClean="0"/>
               <a:t>Second level</a:t>
             </a:r>
           </a:p>
           <a:p>
             <a:pPr lvl="2"/>
             <a:r>
-              <a:rPr lang="en-US"/>
+              <a:rPr lang="en-US" smtClean="0"/>
               <a:t>Third level</a:t>
             </a:r>
           </a:p>
           <a:p>
             <a:pPr lvl="3"/>
             <a:r>
-              <a:rPr lang="en-US"/>
+              <a:rPr lang="en-US" smtClean="0"/>
               <a:t>Fourth level</a:t>
             </a:r>
           </a:p>
           <a:p>
             <a:pPr lvl="4"/>
             <a:r>
-              <a:rPr lang="en-US"/>
+              <a:rPr lang="en-US" smtClean="0"/>
               <a:t>Fifth level</a:t>
             </a:r>
+            <a:endParaRPr lang="en-US"/>
           </a:p>
         </p:txBody>
       </p:sp>
@@ -1800,7 +1770,7 @@
           <a:p>
             <a:fld id="{5BCAD085-E8A6-8845-BD4E-CB4CCA059FC4}" type="datetimeFigureOut">
               <a:rPr lang="en-US" smtClean="0"/>
-              <a:t>8/13/2026</a:t>
+              <a:t>1/27/13</a:t>
             </a:fld>
             <a:endParaRPr lang="en-US"/>
           </a:p>
@@ -1894,9 +1864,10 @@
           <a:lstStyle/>
           <a:p>
             <a:r>
-              <a:rPr lang="en-US"/>
+              <a:rPr lang="en-US" smtClean="0"/>
               <a:t>Click to edit Master title style</a:t>
             </a:r>
+            <a:endParaRPr lang="en-US"/>
           </a:p>
         </p:txBody>
       </p:sp>
@@ -1917,7 +1888,7 @@
           <a:p>
             <a:fld id="{5BCAD085-E8A6-8845-BD4E-CB4CCA059FC4}" type="datetimeFigureOut">
               <a:rPr lang="en-US" smtClean="0"/>
-              <a:t>8/13/2026</a:t>
+              <a:t>1/27/13</a:t>
             </a:fld>
             <a:endParaRPr lang="en-US"/>
           </a:p>
@@ -2012,7 +1983,7 @@
           <a:p>
             <a:fld id="{5BCAD085-E8A6-8845-BD4E-CB4CCA059FC4}" type="datetimeFigureOut">
               <a:rPr lang="en-US" smtClean="0"/>
-              <a:t>8/13/2026</a:t>
+              <a:t>1/27/13</a:t>
             </a:fld>
             <a:endParaRPr lang="en-US"/>
           </a:p>
@@ -2115,9 +2086,10 @@
           </a:lstStyle>
           <a:p>
             <a:r>
-              <a:rPr lang="en-US"/>
+              <a:rPr lang="en-US" smtClean="0"/>
               <a:t>Click to edit Master title style</a:t>
             </a:r>
+            <a:endParaRPr lang="en-US"/>
           </a:p>
         </p:txBody>
       </p:sp>
@@ -2171,37 +2143,38 @@
           <a:p>
             <a:pPr lvl="0"/>
             <a:r>
-              <a:rPr lang="en-US"/>
+              <a:rPr lang="en-US" smtClean="0"/>
               <a:t>Click to edit Master text styles</a:t>
             </a:r>
           </a:p>
           <a:p>
             <a:pPr lvl="1"/>
             <a:r>
-              <a:rPr lang="en-US"/>
+              <a:rPr lang="en-US" smtClean="0"/>
               <a:t>Second level</a:t>
             </a:r>
           </a:p>
           <a:p>
             <a:pPr lvl="2"/>
             <a:r>
-              <a:rPr lang="en-US"/>
+              <a:rPr lang="en-US" smtClean="0"/>
               <a:t>Third level</a:t>
             </a:r>
           </a:p>
           <a:p>
             <a:pPr lvl="3"/>
             <a:r>
-              <a:rPr lang="en-US"/>
+              <a:rPr lang="en-US" smtClean="0"/>
               <a:t>Fourth level</a:t>
             </a:r>
           </a:p>
           <a:p>
             <a:pPr lvl="4"/>
             <a:r>
-              <a:rPr lang="en-US"/>
+              <a:rPr lang="en-US" smtClean="0"/>
               <a:t>Fifth level</a:t>
             </a:r>
+            <a:endParaRPr lang="en-US"/>
           </a:p>
         </p:txBody>
       </p:sp>
@@ -2264,7 +2237,7 @@
           <a:p>
             <a:pPr lvl="0"/>
             <a:r>
-              <a:rPr lang="en-US"/>
+              <a:rPr lang="en-US" smtClean="0"/>
               <a:t>Click to edit Master text styles</a:t>
             </a:r>
           </a:p>
@@ -2287,7 +2260,7 @@
           <a:p>
             <a:fld id="{5BCAD085-E8A6-8845-BD4E-CB4CCA059FC4}" type="datetimeFigureOut">
               <a:rPr lang="en-US" smtClean="0"/>
-              <a:t>8/13/2026</a:t>
+              <a:t>1/27/13</a:t>
             </a:fld>
             <a:endParaRPr lang="en-US"/>
           </a:p>
@@ -2390,9 +2363,10 @@
           </a:lstStyle>
           <a:p>
             <a:r>
-              <a:rPr lang="en-US"/>
+              <a:rPr lang="en-US" smtClean="0"/>
               <a:t>Click to edit Master title style</a:t>
             </a:r>
+            <a:endParaRPr lang="en-US"/>
           </a:p>
         </p:txBody>
       </p:sp>
@@ -2516,7 +2490,7 @@
           <a:p>
             <a:pPr lvl="0"/>
             <a:r>
-              <a:rPr lang="en-US"/>
+              <a:rPr lang="en-US" smtClean="0"/>
               <a:t>Click to edit Master text styles</a:t>
             </a:r>
           </a:p>
@@ -2539,7 +2513,7 @@
           <a:p>
             <a:fld id="{5BCAD085-E8A6-8845-BD4E-CB4CCA059FC4}" type="datetimeFigureOut">
               <a:rPr lang="en-US" smtClean="0"/>
-              <a:t>8/13/2026</a:t>
+              <a:t>1/27/13</a:t>
             </a:fld>
             <a:endParaRPr lang="en-US"/>
           </a:p>
@@ -2648,9 +2622,10 @@
           <a:lstStyle/>
           <a:p>
             <a:r>
-              <a:rPr lang="en-US"/>
+              <a:rPr lang="en-US" smtClean="0"/>
               <a:t>Click to edit Master title style</a:t>
             </a:r>
+            <a:endParaRPr lang="en-US"/>
           </a:p>
         </p:txBody>
       </p:sp>
@@ -2681,37 +2656,38 @@
           <a:p>
             <a:pPr lvl="0"/>
             <a:r>
-              <a:rPr lang="en-US"/>
+              <a:rPr lang="en-US" smtClean="0"/>
               <a:t>Click to edit Master text styles</a:t>
             </a:r>
           </a:p>
           <a:p>
             <a:pPr lvl="1"/>
             <a:r>
-              <a:rPr lang="en-US"/>
+              <a:rPr lang="en-US" smtClean="0"/>
               <a:t>Second level</a:t>
             </a:r>
           </a:p>
           <a:p>
             <a:pPr lvl="2"/>
             <a:r>
-              <a:rPr lang="en-US"/>
+              <a:rPr lang="en-US" smtClean="0"/>
               <a:t>Third level</a:t>
             </a:r>
           </a:p>
           <a:p>
             <a:pPr lvl="3"/>
             <a:r>
-              <a:rPr lang="en-US"/>
+              <a:rPr lang="en-US" smtClean="0"/>
               <a:t>Fourth level</a:t>
             </a:r>
           </a:p>
           <a:p>
             <a:pPr lvl="4"/>
             <a:r>
-              <a:rPr lang="en-US"/>
+              <a:rPr lang="en-US" smtClean="0"/>
               <a:t>Fifth level</a:t>
             </a:r>
+            <a:endParaRPr lang="en-US"/>
           </a:p>
         </p:txBody>
       </p:sp>
@@ -2750,7 +2726,7 @@
           <a:p>
             <a:fld id="{5BCAD085-E8A6-8845-BD4E-CB4CCA059FC4}" type="datetimeFigureOut">
               <a:rPr lang="en-US" smtClean="0"/>
-              <a:t>8/13/2026</a:t>
+              <a:t>1/27/13</a:t>
             </a:fld>
             <a:endParaRPr lang="en-US"/>
           </a:p>
@@ -3109,7 +3085,7 @@
 </file>
 
 <file path=ppt/slides/slide1.xml><?xml version="1.0" encoding="utf-8"?>
-<p:sld xmlns:a="http://schemas.openxmlformats.org/drawingml/2006/main" xmlns:r="http://schemas.openxmlformats.org/officeDocument/2006/relationships" xmlns:p="http://schemas.openxmlformats.org/presentationml/2006/main">
+<p:sld xmlns:a="http://schemas.openxmlformats.org/drawingml/2006/main" xmlns:p="http://schemas.openxmlformats.org/presentationml/2006/main" xmlns:r="http://schemas.openxmlformats.org/officeDocument/2006/relationships">
   <p:cSld>
     <p:bg>
       <p:bgPr>
@@ -3125,14 +3101,7 @@
         <p:cNvGrpSpPr/>
         <p:nvPr/>
       </p:nvGrpSpPr>
-      <p:grpSpPr>
-        <a:xfrm>
-          <a:off x="0" y="0"/>
-          <a:ext cx="0" cy="0"/>
-          <a:chOff x="0" y="0"/>
-          <a:chExt cx="0" cy="0"/>
-        </a:xfrm>
-      </p:grpSpPr>
+      <p:grpSpPr/>
       <p:sp>
         <p:nvSpPr>
           <p:cNvPr id="2" name="Title 1"/>
@@ -3200,7 +3169,7 @@
 </file>
 
 <file path=ppt/slides/slide2.xml><?xml version="1.0" encoding="utf-8"?>
-<p:sld xmlns:a="http://schemas.openxmlformats.org/drawingml/2006/main" xmlns:r="http://schemas.openxmlformats.org/officeDocument/2006/relationships" xmlns:p="http://schemas.openxmlformats.org/presentationml/2006/main">
+<p:sld xmlns:a="http://schemas.openxmlformats.org/drawingml/2006/main" xmlns:p="http://schemas.openxmlformats.org/presentationml/2006/main" xmlns:r="http://schemas.openxmlformats.org/officeDocument/2006/relationships">
   <p:cSld>
     <p:bg>
       <p:bgPr>
@@ -3216,14 +3185,7 @@
         <p:cNvGrpSpPr/>
         <p:nvPr/>
       </p:nvGrpSpPr>
-      <p:grpSpPr>
-        <a:xfrm>
-          <a:off x="0" y="0"/>
-          <a:ext cx="0" cy="0"/>
-          <a:chOff x="0" y="0"/>
-          <a:chExt cx="0" cy="0"/>
-        </a:xfrm>
-      </p:grpSpPr>
+      <p:grpSpPr/>
       <p:sp>
         <p:nvSpPr>
           <p:cNvPr id="2" name="Title 1"/>
@@ -3267,9 +3229,7 @@
         <p:txBody>
           <a:bodyPr/>
           <a:lstStyle/>
-          <a:p>
-            <a:endParaRPr/>
-          </a:p>
+          <a:p/>
           <a:p>
             <a:pPr>
               <a:defRPr sz="2000">
@@ -3372,7 +3332,7 @@
 </file>
 
 <file path=ppt/slides/slide3.xml><?xml version="1.0" encoding="utf-8"?>
-<p:sld xmlns:a="http://schemas.openxmlformats.org/drawingml/2006/main" xmlns:r="http://schemas.openxmlformats.org/officeDocument/2006/relationships" xmlns:p="http://schemas.openxmlformats.org/presentationml/2006/main">
+<p:sld xmlns:a="http://schemas.openxmlformats.org/drawingml/2006/main" xmlns:p="http://schemas.openxmlformats.org/presentationml/2006/main" xmlns:r="http://schemas.openxmlformats.org/officeDocument/2006/relationships">
   <p:cSld>
     <p:bg>
       <p:bgPr>
@@ -3388,14 +3348,7 @@
         <p:cNvGrpSpPr/>
         <p:nvPr/>
       </p:nvGrpSpPr>
-      <p:grpSpPr>
-        <a:xfrm>
-          <a:off x="0" y="0"/>
-          <a:ext cx="0" cy="0"/>
-          <a:chOff x="0" y="0"/>
-          <a:chExt cx="0" cy="0"/>
-        </a:xfrm>
-      </p:grpSpPr>
+      <p:grpSpPr/>
       <p:sp>
         <p:nvSpPr>
           <p:cNvPr id="2" name="Title 1"/>
@@ -3439,9 +3392,7 @@
         <p:txBody>
           <a:bodyPr/>
           <a:lstStyle/>
-          <a:p>
-            <a:endParaRPr/>
-          </a:p>
+          <a:p/>
           <a:p>
             <a:pPr>
               <a:defRPr sz="2000">
@@ -3452,7 +3403,7 @@
               </a:defRPr>
             </a:pPr>
             <a:r>
-              <a:t>Trained on a meticulously curated dataset of 7,200 MRI scans.</a:t>
+              <a:t>Trained on a meticulously curated Mega-Dataset of 13,100+ MRI scans.</a:t>
             </a:r>
           </a:p>
           <a:p>
@@ -3531,7 +3482,7 @@
 </file>
 
 <file path=ppt/slides/slide4.xml><?xml version="1.0" encoding="utf-8"?>
-<p:sld xmlns:a="http://schemas.openxmlformats.org/drawingml/2006/main" xmlns:r="http://schemas.openxmlformats.org/officeDocument/2006/relationships" xmlns:p="http://schemas.openxmlformats.org/presentationml/2006/main">
+<p:sld xmlns:a="http://schemas.openxmlformats.org/drawingml/2006/main" xmlns:p="http://schemas.openxmlformats.org/presentationml/2006/main" xmlns:r="http://schemas.openxmlformats.org/officeDocument/2006/relationships">
   <p:cSld>
     <p:bg>
       <p:bgPr>
@@ -3547,14 +3498,7 @@
         <p:cNvGrpSpPr/>
         <p:nvPr/>
       </p:nvGrpSpPr>
-      <p:grpSpPr>
-        <a:xfrm>
-          <a:off x="0" y="0"/>
-          <a:ext cx="0" cy="0"/>
-          <a:chOff x="0" y="0"/>
-          <a:chExt cx="0" cy="0"/>
-        </a:xfrm>
-      </p:grpSpPr>
+      <p:grpSpPr/>
       <p:sp>
         <p:nvSpPr>
           <p:cNvPr id="2" name="Title 1"/>
@@ -3598,9 +3542,7 @@
         <p:txBody>
           <a:bodyPr/>
           <a:lstStyle/>
-          <a:p>
-            <a:endParaRPr/>
-          </a:p>
+          <a:p/>
           <a:p>
             <a:pPr>
               <a:defRPr sz="2000">
@@ -3611,7 +3553,7 @@
               </a:defRPr>
             </a:pPr>
             <a:r>
-              <a:t>EfficientNetB0 (Fine-Tuned): Deepest 30 layers unfrozen to adapt to MRI textural gradients.</a:t>
+              <a:t>DenseNet121 (Fine-Tuned): Deepest 40 layers unfrozen to adapt to MRI textural gradients.</a:t>
             </a:r>
           </a:p>
           <a:p>
@@ -3637,7 +3579,7 @@
               </a:defRPr>
             </a:pPr>
             <a:r>
-              <a:t>Multi-Model Ensembling: Parallel inference engines ensure blind-spots are corrected instantly.</a:t>
+              <a:t>Clinical Diversity: Merged multiple datasets to eliminate overfitting.</a:t>
             </a:r>
           </a:p>
         </p:txBody>
@@ -3651,7 +3593,7 @@
 </file>
 
 <file path=ppt/slides/slide5.xml><?xml version="1.0" encoding="utf-8"?>
-<p:sld xmlns:a="http://schemas.openxmlformats.org/drawingml/2006/main" xmlns:r="http://schemas.openxmlformats.org/officeDocument/2006/relationships" xmlns:p="http://schemas.openxmlformats.org/presentationml/2006/main">
+<p:sld xmlns:a="http://schemas.openxmlformats.org/drawingml/2006/main" xmlns:p="http://schemas.openxmlformats.org/presentationml/2006/main" xmlns:r="http://schemas.openxmlformats.org/officeDocument/2006/relationships">
   <p:cSld>
     <p:bg>
       <p:bgPr>
@@ -3667,14 +3609,7 @@
         <p:cNvGrpSpPr/>
         <p:nvPr/>
       </p:nvGrpSpPr>
-      <p:grpSpPr>
-        <a:xfrm>
-          <a:off x="0" y="0"/>
-          <a:ext cx="0" cy="0"/>
-          <a:chOff x="0" y="0"/>
-          <a:chExt cx="0" cy="0"/>
-        </a:xfrm>
-      </p:grpSpPr>
+      <p:grpSpPr/>
       <p:sp>
         <p:nvSpPr>
           <p:cNvPr id="2" name="Title 1"/>
@@ -3718,9 +3653,7 @@
         <p:txBody>
           <a:bodyPr/>
           <a:lstStyle/>
-          <a:p>
-            <a:endParaRPr/>
-          </a:p>
+          <a:p/>
           <a:p>
             <a:pPr>
               <a:defRPr sz="2000">
@@ -3731,7 +3664,7 @@
               </a:defRPr>
             </a:pPr>
             <a:r>
-              <a:t>93% Overall Accuracy achieved after deep fine-tuning.</a:t>
+              <a:t>95% Overall Accuracy achieved after deep fine-tuning.</a:t>
             </a:r>
           </a:p>
           <a:p>
@@ -3744,7 +3677,7 @@
               </a:defRPr>
             </a:pPr>
             <a:r>
-              <a:t>100% Recall for 'No Tumor' (Zero false negatives for healthy brains).</a:t>
+              <a:t>98% Recall for 'No Tumor' (Prioritizing safe diagnosis).</a:t>
             </a:r>
           </a:p>
           <a:p>
@@ -3757,7 +3690,7 @@
               </a:defRPr>
             </a:pPr>
             <a:r>
-              <a:t>98% Precision for Gliomas (Extreme confidence in malignant detection).</a:t>
+              <a:t>100% Recall for Pituitary Tumors (Extreme detection confidence).</a:t>
             </a:r>
           </a:p>
           <a:p>
@@ -3784,7 +3717,7 @@
 </file>
 
 <file path=ppt/slides/slide6.xml><?xml version="1.0" encoding="utf-8"?>
-<p:sld xmlns:a="http://schemas.openxmlformats.org/drawingml/2006/main" xmlns:r="http://schemas.openxmlformats.org/officeDocument/2006/relationships" xmlns:p="http://schemas.openxmlformats.org/presentationml/2006/main">
+<p:sld xmlns:a="http://schemas.openxmlformats.org/drawingml/2006/main" xmlns:p="http://schemas.openxmlformats.org/presentationml/2006/main" xmlns:r="http://schemas.openxmlformats.org/officeDocument/2006/relationships">
   <p:cSld>
     <p:bg>
       <p:bgPr>
@@ -3800,14 +3733,7 @@
         <p:cNvGrpSpPr/>
         <p:nvPr/>
       </p:nvGrpSpPr>
-      <p:grpSpPr>
-        <a:xfrm>
-          <a:off x="0" y="0"/>
-          <a:ext cx="0" cy="0"/>
-          <a:chOff x="0" y="0"/>
-          <a:chExt cx="0" cy="0"/>
-        </a:xfrm>
-      </p:grpSpPr>
+      <p:grpSpPr/>
       <p:sp>
         <p:nvSpPr>
           <p:cNvPr id="2" name="Title 1"/>
@@ -3851,9 +3777,7 @@
         <p:txBody>
           <a:bodyPr/>
           <a:lstStyle/>
-          <a:p>
-            <a:endParaRPr/>
-          </a:p>
+          <a:p/>
           <a:p>
             <a:pPr>
               <a:defRPr sz="2000">
@@ -3917,7 +3841,7 @@
 </file>
 
 <file path=ppt/slides/slide7.xml><?xml version="1.0" encoding="utf-8"?>
-<p:sld xmlns:a="http://schemas.openxmlformats.org/drawingml/2006/main" xmlns:r="http://schemas.openxmlformats.org/officeDocument/2006/relationships" xmlns:p="http://schemas.openxmlformats.org/presentationml/2006/main">
+<p:sld xmlns:a="http://schemas.openxmlformats.org/drawingml/2006/main" xmlns:p="http://schemas.openxmlformats.org/presentationml/2006/main" xmlns:r="http://schemas.openxmlformats.org/officeDocument/2006/relationships">
   <p:cSld>
     <p:bg>
       <p:bgPr>
@@ -3933,14 +3857,7 @@
         <p:cNvGrpSpPr/>
         <p:nvPr/>
       </p:nvGrpSpPr>
-      <p:grpSpPr>
-        <a:xfrm>
-          <a:off x="0" y="0"/>
-          <a:ext cx="0" cy="0"/>
-          <a:chOff x="0" y="0"/>
-          <a:chExt cx="0" cy="0"/>
-        </a:xfrm>
-      </p:grpSpPr>
+      <p:grpSpPr/>
       <p:sp>
         <p:nvSpPr>
           <p:cNvPr id="2" name="Title 1"/>
@@ -3994,7 +3911,6 @@
               </a:defRPr>
             </a:pPr>
             <a:r>
-              <a:rPr dirty="0"/>
               <a:t>Thank You</a:t>
             </a:r>
           </a:p>
@@ -4008,24 +3924,8 @@
               </a:defRPr>
             </a:pPr>
             <a:r>
-              <a:rPr dirty="0"/>
               <a:t>Designed by Ashu</a:t>
             </a:r>
-            <a:r>
-              <a:rPr lang="en-IN"/>
-              <a:t>tosh</a:t>
-            </a:r>
-          </a:p>
-          <a:p>
-            <a:pPr>
-              <a:defRPr sz="2800">
-                <a:solidFill>
-                  <a:srgbClr val="00E6FF"/>
-                </a:solidFill>
-                <a:latin typeface="Century Gothic"/>
-              </a:defRPr>
-            </a:pPr>
-            <a:endParaRPr dirty="0"/>
           </a:p>
         </p:txBody>
       </p:sp>

</xml_diff>